<commit_message>
Add dedicated data augmentation slide to presentation
Insert new Slide 4 "Data augmentation: x7 effective training set" between
the training-data and method slides. Deck is now 8 main slides plus 1
hidden backup (was 7 + 1).

- presentation_notebooks/make_augmentation_figure.py: new matplotlib
  fan-out diagram (1 clip -> 5 aug operations -> 7 variants) with
  per-operation parameter ranges.
- figures/augmentation_pipeline.png: generated figure.
- make_pptx.py: insert new slide 4, renumber slides 4-7 -> 5-8 and
  backup -> 9. Slide 5 method bullet list no longer duplicates the
  augmentation bullet since it has its own slide.
- speaker_notes.md: add Slide 4 script (~0:35), renumber downstream
  slides, update rehearsal checklist and time budget (5:10 cumulative).

https://claude.ai/code/session_01GRhKW3iKJjm2wYYeUd56Hq
</commit_message>
<xml_diff>
--- a/presentation_notebooks/primate_detection_presentation.pptx
+++ b/presentation_notebooks/primate_detection_presentation.pptx
@@ -13,6 +13,7 @@
     <p:sldId id="261" r:id="rId13"/>
     <p:sldId id="262" r:id="rId14"/>
     <p:sldId id="263" r:id="rId15"/>
+    <p:sldId id="264" r:id="rId16"/>
   </p:sldIdLst>
   <p:sldSz cx="12191695" cy="6858000" type="screen4x3"/>
   <p:notesSz cx="6858000" cy="9144000"/>
@@ -719,7 +720,7 @@
           <a:lstStyle/>
           <a:p>
             <a:r>
-              <a:t>(1:00) The core idea is simple: treat audio classification as image classification. We take a 5-second sliding window, convert it to a mel-spectrogram, resize to 224x224, and feed it to a VGG19 network pre-trained on ImageNet. The low-level features VGG19 learned on natural images — edges, textures — are exactly what distinguishes spectrograms of different calls. We freeze the backbone and train only a small custom head. Augmentation (background mixing at varying SNR, time / frequency cropping) pushes the 870 clips to ~6,000 effective training samples.</a:t>
+              <a:t>(0:35) 870 clips is a small training set for a deep network, so data augmentation does a lot of the heavy lifting. From each input spectrogram we generate seven variants: the original, three background-noise mixes at randomised SNR between −5 and +10 dB (so the model learns to hear calls through forest noise), one time-axis crop and one frequency-axis crop of 10–30 %, and one frequency translation of up to ±20 mel bins. That pushes the effective training set to around 6,000 samples and — just as importantly — teaches the model to be invariant to background, timing, and small pitch shifts.</a:t>
             </a:r>
           </a:p>
         </p:txBody>
@@ -789,7 +790,7 @@
           <a:lstStyle/>
           <a:p>
             <a:r>
-              <a:t>(1:00) On a held-out validation set the model reaches 94.3% accuracy across the four classes. The confusion matrix tells a more nuanced story — look at the diagonal: Cercopithecus and Colobus recall is above 90%. The hardest class is the background class, where some samples get mis-labelled as Cercopithecus — which makes sense because many background clips contain distantly calling monkeys.</a:t>
+              <a:t>(0:50) The core idea is simple: treat audio classification as image classification. We take a 5-second sliding window, convert it to a mel-spectrogram, resize to 224x224, and feed it to a VGG19 network pre-trained on ImageNet. The low-level features VGG19 learned on natural images — edges, textures — are exactly what distinguishes spectrograms of different calls. We freeze the backbone and train only a small custom head: global average pooling, 512-unit dense, 256-unit dense, 4-way softmax.</a:t>
             </a:r>
           </a:p>
         </p:txBody>
@@ -859,7 +860,7 @@
           <a:lstStyle/>
           <a:p>
             <a:r>
-              <a:t>(1:10) Validation accuracy on clean clips is not what matters — what matters is whether it works on real multi-hour field audio. We ran the model on 13 recordings from Makokou on June 9 2022, morning to night. Practical surprise: the default confidence threshold of 0.7 was way too strict. A threshold sweep showed the confidence distribution is bimodal — the model is either very sure or it assigns the window to background — so we settled on 0.4, below which the detection count saturates. That gave us 44 detections across the 13 files. Parsing the timestamp out of each filename lets us plot detections by hour of day, which recovers meaningful diurnal activity patterns. (Play a detected clip if the room has audio.)</a:t>
+              <a:t>(1:00) On a held-out validation set the model reaches 94.3% accuracy across the four classes. The confusion matrix tells a more nuanced story — look at the diagonal: Cercopithecus and Colobus recall is above 90%. The hardest class is the background class, where some samples get mis-labelled as Cercopithecus — which makes sense because many background clips contain distantly calling monkeys.</a:t>
             </a:r>
           </a:p>
         </p:txBody>
@@ -929,7 +930,7 @@
           <a:lstStyle/>
           <a:p>
             <a:r>
-              <a:t>(0:20) Three takeaways: VGG19 transfer learning works well for primate vocal classification (94% on clean clips); deployed end-to-end on real 2022 field recordings it recovers meaningful diurnal activity patterns; and the whole pipeline is released as a reusable Python package — any researcher with their own primate recordings can run it by editing one config file. Main open challenge: Pan troglodytes recall. Next steps: more field data, per-call-type classification, temporal context. Thank you — happy to take questions.</a:t>
+              <a:t>(1:10) Validation accuracy on clean clips is not what matters — what matters is whether it works on real multi-hour field audio. We ran the model on 13 recordings from Makokou on June 9 2022, morning to night. Practical surprise: the default confidence threshold of 0.7 was way too strict. A threshold sweep showed the confidence distribution is bimodal — the model is either very sure or it assigns the window to background — so we settled on 0.4, below which the detection count saturates. That gave us 44 detections across the 13 files. Parsing the timestamp out of each filename lets us plot detections by hour of day, which recovers meaningful diurnal activity patterns. (Play a detected clip if the room has audio.)</a:t>
             </a:r>
           </a:p>
         </p:txBody>
@@ -955,6 +956,76 @@
 </file>
 
 <file path=ppt/notesSlides/notesSlide8.xml><?xml version="1.0" encoding="utf-8"?>
+<p:notes xmlns:a="http://schemas.openxmlformats.org/drawingml/2006/main" xmlns:p="http://schemas.openxmlformats.org/presentationml/2006/main" xmlns:r="http://schemas.openxmlformats.org/officeDocument/2006/relationships">
+  <p:cSld>
+    <p:spTree>
+      <p:nvGrpSpPr>
+        <p:cNvPr id="1" name=""/>
+        <p:cNvGrpSpPr/>
+        <p:nvPr/>
+      </p:nvGrpSpPr>
+      <p:grpSpPr>
+        <a:xfrm>
+          <a:off x="0" y="0"/>
+          <a:ext cx="0" cy="0"/>
+          <a:chOff x="0" y="0"/>
+          <a:chExt cx="0" cy="0"/>
+        </a:xfrm>
+      </p:grpSpPr>
+      <p:sp>
+        <p:nvSpPr>
+          <p:cNvPr id="2" name="Slide Image Placeholder 1"/>
+          <p:cNvSpPr>
+            <a:spLocks noGrp="1"/>
+          </p:cNvSpPr>
+          <p:nvPr>
+            <p:ph type="sldImg" idx="2"/>
+          </p:nvPr>
+        </p:nvSpPr>
+        <p:spPr/>
+      </p:sp>
+      <p:sp>
+        <p:nvSpPr>
+          <p:cNvPr id="3" name="Notes Placeholder 2"/>
+          <p:cNvSpPr>
+            <a:spLocks noGrp="1"/>
+          </p:cNvSpPr>
+          <p:nvPr>
+            <p:ph type="body" idx="3" sz="quarter"/>
+          </p:nvPr>
+        </p:nvSpPr>
+        <p:spPr/>
+        <p:txBody>
+          <a:bodyPr/>
+          <a:lstStyle/>
+          <a:p>
+            <a:r>
+              <a:t>(0:20) Three takeaways: VGG19 transfer learning works well for primate vocal classification (94% on clean clips); deployed end-to-end on real 2022 field recordings it recovers meaningful diurnal activity patterns; and the whole pipeline is released as a reusable Python package — any researcher with their own primate recordings can run it by editing one config file. Main open challenge: Pan troglodytes recall. Next steps: more field data, per-call-type classification, temporal context. Thank you — happy to take questions.</a:t>
+            </a:r>
+          </a:p>
+        </p:txBody>
+      </p:sp>
+      <p:sp>
+        <p:nvSpPr>
+          <p:cNvPr id="4" name="Slide Number Placeholder 3"/>
+          <p:cNvSpPr>
+            <a:spLocks noGrp="1"/>
+          </p:cNvSpPr>
+          <p:nvPr>
+            <p:ph type="sldNum" idx="5" sz="quarter"/>
+          </p:nvPr>
+        </p:nvSpPr>
+        <p:spPr/>
+      </p:sp>
+    </p:spTree>
+  </p:cSld>
+  <p:clrMapOvr>
+    <a:masterClrMapping/>
+  </p:clrMapOvr>
+</p:notes>
+</file>
+
+<file path=ppt/notesSlides/notesSlide9.xml><?xml version="1.0" encoding="utf-8"?>
 <p:notes xmlns:a="http://schemas.openxmlformats.org/drawingml/2006/main" xmlns:p="http://schemas.openxmlformats.org/presentationml/2006/main" xmlns:r="http://schemas.openxmlformats.org/officeDocument/2006/relationships">
   <p:cSld>
     <p:spTree>
@@ -4466,6 +4537,150 @@
                   <a:srgbClr val="2C3E50"/>
                 </a:solidFill>
               </a:rPr>
+              <a:t>Data augmentation: ×7 effective training set</a:t>
+            </a:r>
+          </a:p>
+        </p:txBody>
+      </p:sp>
+      <p:pic>
+        <p:nvPicPr>
+          <p:cNvPr id="3" name="Picture 2" descr="augmentation_pipeline.png"/>
+          <p:cNvPicPr>
+            <a:picLocks noChangeAspect="1"/>
+          </p:cNvPicPr>
+          <p:nvPr/>
+        </p:nvPicPr>
+        <p:blipFill>
+          <a:blip r:embed="rId2"/>
+          <a:stretch>
+            <a:fillRect/>
+          </a:stretch>
+        </p:blipFill>
+        <p:spPr>
+          <a:xfrm>
+            <a:off x="1289834" y="1234440"/>
+            <a:ext cx="9581852" cy="4754880"/>
+          </a:xfrm>
+          <a:prstGeom prst="rect">
+            <a:avLst/>
+          </a:prstGeom>
+        </p:spPr>
+      </p:pic>
+      <p:sp>
+        <p:nvSpPr>
+          <p:cNvPr id="4" name="TextBox 3"/>
+          <p:cNvSpPr txBox="1"/>
+          <p:nvPr/>
+        </p:nvSpPr>
+        <p:spPr>
+          <a:xfrm>
+            <a:off x="548640" y="6126480"/>
+            <a:ext cx="11064240" cy="457200"/>
+          </a:xfrm>
+          <a:prstGeom prst="rect">
+            <a:avLst/>
+          </a:prstGeom>
+          <a:noFill/>
+        </p:spPr>
+        <p:txBody>
+          <a:bodyPr wrap="square" anchor="t">
+            <a:spAutoFit/>
+          </a:bodyPr>
+          <a:lstStyle/>
+          <a:p>
+            <a:pPr algn="ctr"/>
+            <a:r>
+              <a:rPr sz="1400" b="0">
+                <a:solidFill>
+                  <a:srgbClr val="34495E"/>
+                </a:solidFill>
+              </a:rPr>
+              <a:t>Each clip → 7 variants: original, 3× background mix (SNR −5..10 dB), time crop, freq crop, freq translate (±20 bins)</a:t>
+            </a:r>
+          </a:p>
+        </p:txBody>
+      </p:sp>
+      <p:sp>
+        <p:nvSpPr>
+          <p:cNvPr id="5" name="TextBox 4"/>
+          <p:cNvSpPr txBox="1"/>
+          <p:nvPr/>
+        </p:nvSpPr>
+        <p:spPr>
+          <a:xfrm>
+            <a:off x="548640" y="6537960"/>
+            <a:ext cx="11064240" cy="320040"/>
+          </a:xfrm>
+          <a:prstGeom prst="rect">
+            <a:avLst/>
+          </a:prstGeom>
+          <a:noFill/>
+        </p:spPr>
+        <p:txBody>
+          <a:bodyPr wrap="square" anchor="t">
+            <a:spAutoFit/>
+          </a:bodyPr>
+          <a:lstStyle/>
+          <a:p>
+            <a:pPr algn="ctr"/>
+            <a:r>
+              <a:rPr sz="1200" b="0">
+                <a:solidFill>
+                  <a:srgbClr val="7F8C8D"/>
+                </a:solidFill>
+              </a:rPr>
+              <a:t>~870 species clips  →  ~6 000 effective training samples  —  invariance to background noise, timing, and small pitch shifts</a:t>
+            </a:r>
+          </a:p>
+        </p:txBody>
+      </p:sp>
+    </p:spTree>
+  </p:cSld>
+  <p:clrMapOvr>
+    <a:masterClrMapping/>
+  </p:clrMapOvr>
+</p:sld>
+</file>
+
+<file path=ppt/slides/slide5.xml><?xml version="1.0" encoding="utf-8"?>
+<p:sld xmlns:a="http://schemas.openxmlformats.org/drawingml/2006/main" xmlns:p="http://schemas.openxmlformats.org/presentationml/2006/main" xmlns:r="http://schemas.openxmlformats.org/officeDocument/2006/relationships">
+  <p:cSld>
+    <p:spTree>
+      <p:nvGrpSpPr>
+        <p:cNvPr id="1" name=""/>
+        <p:cNvGrpSpPr/>
+        <p:nvPr/>
+      </p:nvGrpSpPr>
+      <p:grpSpPr/>
+      <p:sp>
+        <p:nvSpPr>
+          <p:cNvPr id="2" name="TextBox 1"/>
+          <p:cNvSpPr txBox="1"/>
+          <p:nvPr/>
+        </p:nvSpPr>
+        <p:spPr>
+          <a:xfrm>
+            <a:off x="548640" y="320040"/>
+            <a:ext cx="10972800" cy="822960"/>
+          </a:xfrm>
+          <a:prstGeom prst="rect">
+            <a:avLst/>
+          </a:prstGeom>
+          <a:noFill/>
+        </p:spPr>
+        <p:txBody>
+          <a:bodyPr wrap="square" anchor="t">
+            <a:spAutoFit/>
+          </a:bodyPr>
+          <a:lstStyle/>
+          <a:p>
+            <a:pPr algn="l"/>
+            <a:r>
+              <a:rPr sz="3200" b="1">
+                <a:solidFill>
+                  <a:srgbClr val="2C3E50"/>
+                </a:solidFill>
+              </a:rPr>
               <a:t>Audio-as-image classification via transfer learning</a:t>
             </a:r>
           </a:p>
@@ -4558,7 +4773,7 @@
                   <a:srgbClr val="34495E"/>
                 </a:solidFill>
               </a:rPr>
-              <a:t>•  Augmentation: background mixing (SNR -5..10 dB), time/freq crop, freq translation — ×7 effective training-set multiplier</a:t>
+              <a:t>•  Custom head: GAP → Dense 512 → Dense 256 → 4-way softmax</a:t>
             </a:r>
           </a:p>
         </p:txBody>
@@ -4571,7 +4786,7 @@
 </p:sld>
 </file>
 
-<file path=ppt/slides/slide5.xml><?xml version="1.0" encoding="utf-8"?>
+<file path=ppt/slides/slide6.xml><?xml version="1.0" encoding="utf-8"?>
 <p:sld xmlns:a="http://schemas.openxmlformats.org/drawingml/2006/main" xmlns:p="http://schemas.openxmlformats.org/presentationml/2006/main" xmlns:r="http://schemas.openxmlformats.org/officeDocument/2006/relationships">
   <p:cSld>
     <p:spTree>
@@ -4709,7 +4924,7 @@
 </p:sld>
 </file>
 
-<file path=ppt/slides/slide6.xml><?xml version="1.0" encoding="utf-8"?>
+<file path=ppt/slides/slide7.xml><?xml version="1.0" encoding="utf-8"?>
 <p:sld xmlns:a="http://schemas.openxmlformats.org/drawingml/2006/main" xmlns:p="http://schemas.openxmlformats.org/presentationml/2006/main" xmlns:r="http://schemas.openxmlformats.org/officeDocument/2006/relationships">
   <p:cSld>
     <p:spTree>
@@ -4948,7 +5163,7 @@
 </p:sld>
 </file>
 
-<file path=ppt/slides/slide7.xml><?xml version="1.0" encoding="utf-8"?>
+<file path=ppt/slides/slide8.xml><?xml version="1.0" encoding="utf-8"?>
 <p:sld xmlns:a="http://schemas.openxmlformats.org/drawingml/2006/main" xmlns:p="http://schemas.openxmlformats.org/presentationml/2006/main" xmlns:r="http://schemas.openxmlformats.org/officeDocument/2006/relationships">
   <p:cSld>
     <p:spTree>
@@ -5136,7 +5351,7 @@
 </p:sld>
 </file>
 
-<file path=ppt/slides/slide8.xml><?xml version="1.0" encoding="utf-8"?>
+<file path=ppt/slides/slide9.xml><?xml version="1.0" encoding="utf-8"?>
 <p:sld xmlns:a="http://schemas.openxmlformats.org/drawingml/2006/main" xmlns:p="http://schemas.openxmlformats.org/presentationml/2006/main" xmlns:r="http://schemas.openxmlformats.org/officeDocument/2006/relationships" show="0">
   <p:cSld>
     <p:spTree>

</xml_diff>